<commit_message>
Add files via upload
</commit_message>
<xml_diff>
--- a/PTA_Tool_Testing_Status.pptx
+++ b/PTA_Tool_Testing_Status.pptx
@@ -6140,8 +6140,8 @@
         </p:nvSpPr>
         <p:spPr>
           <a:xfrm>
-            <a:off x="411480" y="868680"/>
-            <a:ext cx="11338560" cy="411480"/>
+            <a:off x="411480" y="896112"/>
+            <a:ext cx="11338560" cy="365760"/>
           </a:xfrm>
           <a:prstGeom prst="rect">
             <a:avLst/>
@@ -6160,7 +6160,7 @@
               </a:spcAft>
             </a:pPr>
             <a:r>
-              <a:rPr sz="1200" b="1">
+              <a:rPr sz="1300" b="1">
                 <a:solidFill>
                   <a:srgbClr val="002060"/>
                 </a:solidFill>
@@ -6169,13 +6169,13 @@
               <a:t>Objective: </a:t>
             </a:r>
             <a:r>
-              <a:rPr sz="1200" b="0">
+              <a:rPr sz="1300" b="0">
                 <a:solidFill>
                   <a:srgbClr val="262626"/>
                 </a:solidFill>
                 <a:latin typeface="Arial"/>
               </a:rPr>
-              <a:t>Confirm that PTA files generated by the automation tool upload to the Power BI dashboard and reflect data correctly, so the manual ~75 min/MI preparation can be replaced.</a:t>
+              <a:t>Validate tool-generated PTA files on the Power BI dashboard.</a:t>
             </a:r>
           </a:p>
         </p:txBody>
@@ -6188,8 +6188,8 @@
         </p:nvSpPr>
         <p:spPr>
           <a:xfrm>
-            <a:off x="411480" y="1353312"/>
-            <a:ext cx="1143000" cy="310896"/>
+            <a:off x="411480" y="1371600"/>
+            <a:ext cx="1188720" cy="365760"/>
           </a:xfrm>
           <a:prstGeom prst="rect">
             <a:avLst/>
@@ -6217,7 +6217,7 @@
           </a:fontRef>
         </p:style>
         <p:txBody>
-          <a:bodyPr rtlCol="0" anchor="ctr" wrap="square" tIns="91440" bIns="91440"/>
+          <a:bodyPr rtlCol="0" anchor="ctr" wrap="square" lIns="109728" rIns="109728" tIns="109728" bIns="109728"/>
           <a:lstStyle/>
           <a:p>
             <a:pPr algn="l">
@@ -6226,7 +6226,7 @@
               </a:spcAft>
             </a:pPr>
             <a:r>
-              <a:rPr sz="1100" b="1">
+              <a:rPr sz="1200" b="1">
                 <a:solidFill>
                   <a:srgbClr val="FFFFFF"/>
                 </a:solidFill>
@@ -6245,8 +6245,8 @@
         </p:nvSpPr>
         <p:spPr>
           <a:xfrm>
-            <a:off x="1645920" y="1353312"/>
-            <a:ext cx="4892040" cy="310896"/>
+            <a:off x="1691640" y="1371600"/>
+            <a:ext cx="4663440" cy="365760"/>
           </a:xfrm>
           <a:prstGeom prst="rect">
             <a:avLst/>
@@ -6274,7 +6274,7 @@
           </a:fontRef>
         </p:style>
         <p:txBody>
-          <a:bodyPr rtlCol="0" anchor="ctr" wrap="square" tIns="91440" bIns="91440"/>
+          <a:bodyPr rtlCol="0" anchor="ctr" wrap="square" lIns="109728" rIns="109728" tIns="109728" bIns="109728"/>
           <a:lstStyle/>
           <a:p>
             <a:pPr algn="l">
@@ -6283,7 +6283,7 @@
               </a:spcAft>
             </a:pPr>
             <a:r>
-              <a:rPr sz="1100" b="1">
+              <a:rPr sz="1200" b="1">
                 <a:solidFill>
                   <a:srgbClr val="FFFFFF"/>
                 </a:solidFill>
@@ -6302,8 +6302,8 @@
         </p:nvSpPr>
         <p:spPr>
           <a:xfrm>
-            <a:off x="6629400" y="1353312"/>
-            <a:ext cx="5166360" cy="310896"/>
+            <a:off x="6446520" y="1371600"/>
+            <a:ext cx="5349240" cy="365760"/>
           </a:xfrm>
           <a:prstGeom prst="rect">
             <a:avLst/>
@@ -6331,7 +6331,7 @@
           </a:fontRef>
         </p:style>
         <p:txBody>
-          <a:bodyPr rtlCol="0" anchor="ctr" wrap="square" tIns="91440" bIns="91440"/>
+          <a:bodyPr rtlCol="0" anchor="ctr" wrap="square" lIns="109728" rIns="109728" tIns="109728" bIns="109728"/>
           <a:lstStyle/>
           <a:p>
             <a:pPr algn="l">
@@ -6340,13 +6340,13 @@
               </a:spcAft>
             </a:pPr>
             <a:r>
-              <a:rPr sz="1100" b="1">
+              <a:rPr sz="1200" b="1">
                 <a:solidFill>
                   <a:srgbClr val="FFFFFF"/>
                 </a:solidFill>
                 <a:latin typeface="Arial"/>
               </a:rPr>
-              <a:t>Result / Observation</a:t>
+              <a:t>Result</a:t>
             </a:r>
           </a:p>
         </p:txBody>
@@ -6359,8 +6359,8 @@
         </p:nvSpPr>
         <p:spPr>
           <a:xfrm>
-            <a:off x="411480" y="1737360"/>
-            <a:ext cx="11384280" cy="731520"/>
+            <a:off x="411480" y="1828800"/>
+            <a:ext cx="11384280" cy="640080"/>
           </a:xfrm>
           <a:prstGeom prst="rect">
             <a:avLst/>
@@ -6401,8 +6401,8 @@
         </p:nvSpPr>
         <p:spPr>
           <a:xfrm>
-            <a:off x="411480" y="1737360"/>
-            <a:ext cx="1143000" cy="731520"/>
+            <a:off x="411480" y="1828800"/>
+            <a:ext cx="1188720" cy="640080"/>
           </a:xfrm>
           <a:prstGeom prst="rect">
             <a:avLst/>
@@ -6410,18 +6410,18 @@
           <a:noFill/>
         </p:spPr>
         <p:txBody>
-          <a:bodyPr wrap="square" anchor="ctr" lIns="109728" rIns="109728" tIns="109728" bIns="109728">
+          <a:bodyPr wrap="square" anchor="ctr" lIns="128016" rIns="128016" tIns="128016" bIns="128016">
             <a:spAutoFit/>
           </a:bodyPr>
           <a:lstStyle/>
           <a:p>
             <a:pPr algn="l">
               <a:spcAft>
-                <a:spcPts val="0"/>
+                <a:spcPts val="200"/>
               </a:spcAft>
             </a:pPr>
             <a:r>
-              <a:rPr sz="1300" b="1">
+              <a:rPr sz="1400" b="1">
                 <a:solidFill>
                   <a:srgbClr val="096082"/>
                 </a:solidFill>
@@ -6430,22 +6430,6 @@
               <a:t>27 Aug</a:t>
             </a:r>
           </a:p>
-          <a:p>
-            <a:pPr algn="l">
-              <a:spcAft>
-                <a:spcPts val="0"/>
-              </a:spcAft>
-            </a:pPr>
-            <a:r>
-              <a:rPr sz="900" b="0">
-                <a:solidFill>
-                  <a:srgbClr val="595959"/>
-                </a:solidFill>
-                <a:latin typeface="Arial"/>
-              </a:rPr>
-              <a:t>2026</a:t>
-            </a:r>
-          </a:p>
         </p:txBody>
       </p:sp>
       <p:sp>
@@ -6456,8 +6440,8 @@
         </p:nvSpPr>
         <p:spPr>
           <a:xfrm>
-            <a:off x="1645920" y="1737360"/>
-            <a:ext cx="4892040" cy="731520"/>
+            <a:off x="1691640" y="1828800"/>
+            <a:ext cx="4663440" cy="640080"/>
           </a:xfrm>
           <a:prstGeom prst="rect">
             <a:avLst/>
@@ -6465,40 +6449,24 @@
           <a:noFill/>
         </p:spPr>
         <p:txBody>
-          <a:bodyPr wrap="square" anchor="ctr" tIns="91440" bIns="91440">
+          <a:bodyPr wrap="square" anchor="ctr" lIns="109728" rIns="109728" tIns="109728" bIns="109728">
             <a:spAutoFit/>
           </a:bodyPr>
           <a:lstStyle/>
           <a:p>
             <a:pPr algn="l">
               <a:spcAft>
-                <a:spcPts val="100"/>
+                <a:spcPts val="200"/>
               </a:spcAft>
             </a:pPr>
             <a:r>
-              <a:rPr sz="1100" b="1">
-                <a:solidFill>
-                  <a:srgbClr val="002060"/>
-                </a:solidFill>
-                <a:latin typeface="Arial"/>
-              </a:rPr>
-              <a:t>Round 1 – Upload test</a:t>
-            </a:r>
-          </a:p>
-          <a:p>
-            <a:pPr algn="l">
-              <a:spcAft>
-                <a:spcPts val="100"/>
-              </a:spcAft>
-            </a:pPr>
-            <a:r>
-              <a:rPr sz="1000" b="0">
+              <a:rPr sz="1400" b="0">
                 <a:solidFill>
                   <a:srgbClr val="262626"/>
                 </a:solidFill>
                 <a:latin typeface="Arial"/>
               </a:rPr>
-              <a:t>Tool-generated CSV files for 2 MIs (485 &amp; 1000) shared with Supreet (McD) for dashboard upload.</a:t>
+              <a:t>Upload test – 2 MIs</a:t>
             </a:r>
           </a:p>
         </p:txBody>
@@ -6511,8 +6479,8 @@
         </p:nvSpPr>
         <p:spPr>
           <a:xfrm>
-            <a:off x="6720840" y="1956816"/>
-            <a:ext cx="960120" cy="292608"/>
+            <a:off x="6556248" y="1984248"/>
+            <a:ext cx="1051560" cy="329184"/>
           </a:xfrm>
           <a:prstGeom prst="roundRect">
             <a:avLst>
@@ -6551,7 +6519,7 @@
               </a:spcAft>
             </a:pPr>
             <a:r>
-              <a:rPr sz="1000" b="1">
+              <a:rPr sz="1100" b="1">
                 <a:solidFill>
                   <a:srgbClr val="FFFFFF"/>
                 </a:solidFill>
@@ -6570,8 +6538,8 @@
         </p:nvSpPr>
         <p:spPr>
           <a:xfrm>
-            <a:off x="7772400" y="1737360"/>
-            <a:ext cx="3977639" cy="731520"/>
+            <a:off x="7726679" y="1828800"/>
+            <a:ext cx="4023360" cy="640080"/>
           </a:xfrm>
           <a:prstGeom prst="rect">
             <a:avLst/>
@@ -6590,13 +6558,13 @@
               </a:spcAft>
             </a:pPr>
             <a:r>
-              <a:rPr sz="1000" b="0">
+              <a:rPr sz="1400" b="0">
                 <a:solidFill>
                   <a:srgbClr val="262626"/>
                 </a:solidFill>
                 <a:latin typeface="Arial"/>
               </a:rPr>
-              <a:t>MI 485 uploaded and flowed through to the dashboard. MI 1000 already existed under the Spicy Nuggets PTA category.</a:t>
+              <a:t>MI 485 reflected on dashboard</a:t>
             </a:r>
           </a:p>
         </p:txBody>
@@ -6609,8 +6577,8 @@
         </p:nvSpPr>
         <p:spPr>
           <a:xfrm>
-            <a:off x="411480" y="2542032"/>
-            <a:ext cx="11384280" cy="731520"/>
+            <a:off x="411480" y="2578608"/>
+            <a:ext cx="11384280" cy="640080"/>
           </a:xfrm>
           <a:prstGeom prst="rect">
             <a:avLst/>
@@ -6651,8 +6619,8 @@
         </p:nvSpPr>
         <p:spPr>
           <a:xfrm>
-            <a:off x="411480" y="2542032"/>
-            <a:ext cx="1143000" cy="731520"/>
+            <a:off x="411480" y="2578608"/>
+            <a:ext cx="1188720" cy="640080"/>
           </a:xfrm>
           <a:prstGeom prst="rect">
             <a:avLst/>
@@ -6660,18 +6628,18 @@
           <a:noFill/>
         </p:spPr>
         <p:txBody>
-          <a:bodyPr wrap="square" anchor="ctr" lIns="109728" rIns="109728" tIns="109728" bIns="109728">
+          <a:bodyPr wrap="square" anchor="ctr" lIns="128016" rIns="128016" tIns="128016" bIns="128016">
             <a:spAutoFit/>
           </a:bodyPr>
           <a:lstStyle/>
           <a:p>
             <a:pPr algn="l">
               <a:spcAft>
-                <a:spcPts val="0"/>
+                <a:spcPts val="200"/>
               </a:spcAft>
             </a:pPr>
             <a:r>
-              <a:rPr sz="1300" b="1">
+              <a:rPr sz="1400" b="1">
                 <a:solidFill>
                   <a:srgbClr val="096082"/>
                 </a:solidFill>
@@ -6680,22 +6648,6 @@
               <a:t>02 Sep</a:t>
             </a:r>
           </a:p>
-          <a:p>
-            <a:pPr algn="l">
-              <a:spcAft>
-                <a:spcPts val="0"/>
-              </a:spcAft>
-            </a:pPr>
-            <a:r>
-              <a:rPr sz="900" b="0">
-                <a:solidFill>
-                  <a:srgbClr val="595959"/>
-                </a:solidFill>
-                <a:latin typeface="Arial"/>
-              </a:rPr>
-              <a:t>2026</a:t>
-            </a:r>
-          </a:p>
         </p:txBody>
       </p:sp>
       <p:sp>
@@ -6706,8 +6658,8 @@
         </p:nvSpPr>
         <p:spPr>
           <a:xfrm>
-            <a:off x="1645920" y="2542032"/>
-            <a:ext cx="4892040" cy="731520"/>
+            <a:off x="1691640" y="2578608"/>
+            <a:ext cx="4663440" cy="640080"/>
           </a:xfrm>
           <a:prstGeom prst="rect">
             <a:avLst/>
@@ -6715,40 +6667,24 @@
           <a:noFill/>
         </p:spPr>
         <p:txBody>
-          <a:bodyPr wrap="square" anchor="ctr" tIns="91440" bIns="91440">
+          <a:bodyPr wrap="square" anchor="ctr" lIns="109728" rIns="109728" tIns="109728" bIns="109728">
             <a:spAutoFit/>
           </a:bodyPr>
           <a:lstStyle/>
           <a:p>
             <a:pPr algn="l">
               <a:spcAft>
-                <a:spcPts val="100"/>
+                <a:spcPts val="200"/>
               </a:spcAft>
             </a:pPr>
             <a:r>
-              <a:rPr sz="1100" b="1">
-                <a:solidFill>
-                  <a:srgbClr val="002060"/>
-                </a:solidFill>
-                <a:latin typeface="Arial"/>
-              </a:rPr>
-              <a:t>Round 2 – % calculation check</a:t>
-            </a:r>
-          </a:p>
-          <a:p>
-            <a:pPr algn="l">
-              <a:spcAft>
-                <a:spcPts val="100"/>
-              </a:spcAft>
-            </a:pPr>
-            <a:r>
-              <a:rPr sz="1000" b="0">
+              <a:rPr sz="1400" b="0">
                 <a:solidFill>
                   <a:srgbClr val="262626"/>
                 </a:solidFill>
                 <a:latin typeface="Arial"/>
               </a:rPr>
-              <a:t>Dashboard showed 98% vs 92% expected – it may be picking the earlier (highest %) file. PTA report for an older MI (MI 5) shared to verify.</a:t>
+              <a:t>% calculation check – older MI</a:t>
             </a:r>
           </a:p>
         </p:txBody>
@@ -6761,8 +6697,8 @@
         </p:nvSpPr>
         <p:spPr>
           <a:xfrm>
-            <a:off x="6720840" y="2761488"/>
-            <a:ext cx="960120" cy="292608"/>
+            <a:off x="6556248" y="2734056"/>
+            <a:ext cx="1051560" cy="329184"/>
           </a:xfrm>
           <a:prstGeom prst="roundRect">
             <a:avLst>
@@ -6801,7 +6737,7 @@
               </a:spcAft>
             </a:pPr>
             <a:r>
-              <a:rPr sz="1000" b="1">
+              <a:rPr sz="1100" b="1">
                 <a:solidFill>
                   <a:srgbClr val="FFFFFF"/>
                 </a:solidFill>
@@ -6820,8 +6756,8 @@
         </p:nvSpPr>
         <p:spPr>
           <a:xfrm>
-            <a:off x="7772400" y="2542032"/>
-            <a:ext cx="3977639" cy="731520"/>
+            <a:off x="7726679" y="2578608"/>
+            <a:ext cx="4023360" cy="640080"/>
           </a:xfrm>
           <a:prstGeom prst="rect">
             <a:avLst/>
@@ -6840,13 +6776,13 @@
               </a:spcAft>
             </a:pPr>
             <a:r>
-              <a:rPr sz="1000" b="0">
+              <a:rPr sz="1400" b="0">
                 <a:solidFill>
                   <a:srgbClr val="262626"/>
                 </a:solidFill>
                 <a:latin typeface="Arial"/>
               </a:rPr>
-              <a:t>MI 5: no data populated on the dashboard and no data found in Cosmos.</a:t>
+              <a:t>No data on dashboard / Cosmos</a:t>
             </a:r>
           </a:p>
         </p:txBody>
@@ -6859,8 +6795,8 @@
         </p:nvSpPr>
         <p:spPr>
           <a:xfrm>
-            <a:off x="411480" y="3346704"/>
-            <a:ext cx="11384280" cy="731520"/>
+            <a:off x="411480" y="3328415"/>
+            <a:ext cx="11384280" cy="640080"/>
           </a:xfrm>
           <a:prstGeom prst="rect">
             <a:avLst/>
@@ -6901,8 +6837,8 @@
         </p:nvSpPr>
         <p:spPr>
           <a:xfrm>
-            <a:off x="411480" y="3346704"/>
-            <a:ext cx="1143000" cy="731520"/>
+            <a:off x="411480" y="3328415"/>
+            <a:ext cx="1188720" cy="640080"/>
           </a:xfrm>
           <a:prstGeom prst="rect">
             <a:avLst/>
@@ -6910,18 +6846,18 @@
           <a:noFill/>
         </p:spPr>
         <p:txBody>
-          <a:bodyPr wrap="square" anchor="ctr" lIns="109728" rIns="109728" tIns="109728" bIns="109728">
+          <a:bodyPr wrap="square" anchor="ctr" lIns="128016" rIns="128016" tIns="128016" bIns="128016">
             <a:spAutoFit/>
           </a:bodyPr>
           <a:lstStyle/>
           <a:p>
             <a:pPr algn="l">
               <a:spcAft>
-                <a:spcPts val="0"/>
+                <a:spcPts val="200"/>
               </a:spcAft>
             </a:pPr>
             <a:r>
-              <a:rPr sz="1300" b="1">
+              <a:rPr sz="1400" b="1">
                 <a:solidFill>
                   <a:srgbClr val="096082"/>
                 </a:solidFill>
@@ -6930,22 +6866,6 @@
               <a:t>11 Sep</a:t>
             </a:r>
           </a:p>
-          <a:p>
-            <a:pPr algn="l">
-              <a:spcAft>
-                <a:spcPts val="0"/>
-              </a:spcAft>
-            </a:pPr>
-            <a:r>
-              <a:rPr sz="900" b="0">
-                <a:solidFill>
-                  <a:srgbClr val="595959"/>
-                </a:solidFill>
-                <a:latin typeface="Arial"/>
-              </a:rPr>
-              <a:t>2026</a:t>
-            </a:r>
-          </a:p>
         </p:txBody>
       </p:sp>
       <p:sp>
@@ -6956,8 +6876,8 @@
         </p:nvSpPr>
         <p:spPr>
           <a:xfrm>
-            <a:off x="1645920" y="3346704"/>
-            <a:ext cx="4892040" cy="731520"/>
+            <a:off x="1691640" y="3328415"/>
+            <a:ext cx="4663440" cy="640080"/>
           </a:xfrm>
           <a:prstGeom prst="rect">
             <a:avLst/>
@@ -6965,40 +6885,24 @@
           <a:noFill/>
         </p:spPr>
         <p:txBody>
-          <a:bodyPr wrap="square" anchor="ctr" tIns="91440" bIns="91440">
+          <a:bodyPr wrap="square" anchor="ctr" lIns="109728" rIns="109728" tIns="109728" bIns="109728">
             <a:spAutoFit/>
           </a:bodyPr>
           <a:lstStyle/>
           <a:p>
             <a:pPr algn="l">
               <a:spcAft>
-                <a:spcPts val="100"/>
+                <a:spcPts val="200"/>
               </a:spcAft>
             </a:pPr>
             <a:r>
-              <a:rPr sz="1100" b="1">
-                <a:solidFill>
-                  <a:srgbClr val="002060"/>
-                </a:solidFill>
-                <a:latin typeface="Arial"/>
-              </a:rPr>
-              <a:t>Round 3 – Scenario testing</a:t>
-            </a:r>
-          </a:p>
-          <a:p>
-            <a:pPr algn="l">
-              <a:spcAft>
-                <a:spcPts val="100"/>
-              </a:spcAft>
-            </a:pPr>
-            <a:r>
-              <a:rPr sz="1000" b="0">
+              <a:rPr sz="1400" b="0">
                 <a:solidFill>
                   <a:srgbClr val="262626"/>
                 </a:solidFill>
                 <a:latin typeface="Arial"/>
               </a:rPr>
-              <a:t>Tool files for several MIs covering different scenarios (newly created and existing MIs) shared to find a pattern.</a:t>
+              <a:t>Multiple MI scenarios (new + existing)</a:t>
             </a:r>
           </a:p>
         </p:txBody>
@@ -7011,8 +6915,8 @@
         </p:nvSpPr>
         <p:spPr>
           <a:xfrm>
-            <a:off x="6720840" y="3566160"/>
-            <a:ext cx="960120" cy="292608"/>
+            <a:off x="6556248" y="3483863"/>
+            <a:ext cx="1051560" cy="329184"/>
           </a:xfrm>
           <a:prstGeom prst="roundRect">
             <a:avLst>
@@ -7051,7 +6955,7 @@
               </a:spcAft>
             </a:pPr>
             <a:r>
-              <a:rPr sz="1000" b="1">
+              <a:rPr sz="1100" b="1">
                 <a:solidFill>
                   <a:srgbClr val="FFFFFF"/>
                 </a:solidFill>
@@ -7070,8 +6974,8 @@
         </p:nvSpPr>
         <p:spPr>
           <a:xfrm>
-            <a:off x="7772400" y="3346704"/>
-            <a:ext cx="3977639" cy="731520"/>
+            <a:off x="7726679" y="3328415"/>
+            <a:ext cx="4023360" cy="640080"/>
           </a:xfrm>
           <a:prstGeom prst="rect">
             <a:avLst/>
@@ -7090,13 +6994,13 @@
               </a:spcAft>
             </a:pPr>
             <a:r>
-              <a:rPr sz="1000" b="0">
+              <a:rPr sz="1400" b="0">
                 <a:solidFill>
                   <a:srgbClr val="262626"/>
                 </a:solidFill>
                 <a:latin typeface="Arial"/>
               </a:rPr>
-              <a:t>No data populating – checked in Cosmos and Power BI, data not available.</a:t>
+              <a:t>No data in Cosmos / Power BI</a:t>
             </a:r>
           </a:p>
         </p:txBody>
@@ -7109,8 +7013,8 @@
         </p:nvSpPr>
         <p:spPr>
           <a:xfrm>
-            <a:off x="411480" y="4151376"/>
-            <a:ext cx="11384280" cy="731520"/>
+            <a:off x="411480" y="4078224"/>
+            <a:ext cx="11384280" cy="640080"/>
           </a:xfrm>
           <a:prstGeom prst="rect">
             <a:avLst/>
@@ -7151,8 +7055,8 @@
         </p:nvSpPr>
         <p:spPr>
           <a:xfrm>
-            <a:off x="411480" y="4151376"/>
-            <a:ext cx="1143000" cy="731520"/>
+            <a:off x="411480" y="4078224"/>
+            <a:ext cx="1188720" cy="640080"/>
           </a:xfrm>
           <a:prstGeom prst="rect">
             <a:avLst/>
@@ -7160,18 +7064,18 @@
           <a:noFill/>
         </p:spPr>
         <p:txBody>
-          <a:bodyPr wrap="square" anchor="ctr" lIns="109728" rIns="109728" tIns="109728" bIns="109728">
+          <a:bodyPr wrap="square" anchor="ctr" lIns="128016" rIns="128016" tIns="128016" bIns="128016">
             <a:spAutoFit/>
           </a:bodyPr>
           <a:lstStyle/>
           <a:p>
             <a:pPr algn="l">
               <a:spcAft>
-                <a:spcPts val="0"/>
+                <a:spcPts val="200"/>
               </a:spcAft>
             </a:pPr>
             <a:r>
-              <a:rPr sz="1300" b="1">
+              <a:rPr sz="1400" b="1">
                 <a:solidFill>
                   <a:srgbClr val="096082"/>
                 </a:solidFill>
@@ -7180,22 +7084,6 @@
               <a:t>22 Sep</a:t>
             </a:r>
           </a:p>
-          <a:p>
-            <a:pPr algn="l">
-              <a:spcAft>
-                <a:spcPts val="0"/>
-              </a:spcAft>
-            </a:pPr>
-            <a:r>
-              <a:rPr sz="900" b="0">
-                <a:solidFill>
-                  <a:srgbClr val="595959"/>
-                </a:solidFill>
-                <a:latin typeface="Arial"/>
-              </a:rPr>
-              <a:t>2026</a:t>
-            </a:r>
-          </a:p>
         </p:txBody>
       </p:sp>
       <p:sp>
@@ -7206,8 +7094,8 @@
         </p:nvSpPr>
         <p:spPr>
           <a:xfrm>
-            <a:off x="1645920" y="4151376"/>
-            <a:ext cx="4892040" cy="731520"/>
+            <a:off x="1691640" y="4078224"/>
+            <a:ext cx="4663440" cy="640080"/>
           </a:xfrm>
           <a:prstGeom prst="rect">
             <a:avLst/>
@@ -7215,40 +7103,24 @@
           <a:noFill/>
         </p:spPr>
         <p:txBody>
-          <a:bodyPr wrap="square" anchor="ctr" tIns="91440" bIns="91440">
+          <a:bodyPr wrap="square" anchor="ctr" lIns="109728" rIns="109728" tIns="109728" bIns="109728">
             <a:spAutoFit/>
           </a:bodyPr>
           <a:lstStyle/>
           <a:p>
             <a:pPr algn="l">
               <a:spcAft>
-                <a:spcPts val="100"/>
+                <a:spcPts val="200"/>
               </a:spcAft>
             </a:pPr>
             <a:r>
-              <a:rPr sz="1100" b="1">
-                <a:solidFill>
-                  <a:srgbClr val="002060"/>
-                </a:solidFill>
-                <a:latin typeface="Arial"/>
-              </a:rPr>
-              <a:t>Round 4 – Manual file comparison</a:t>
-            </a:r>
-          </a:p>
-          <a:p>
-            <a:pPr algn="l">
-              <a:spcAft>
-                <a:spcPts val="100"/>
-              </a:spcAft>
-            </a:pPr>
-            <a:r>
-              <a:rPr sz="1000" b="0">
+              <a:rPr sz="1400" b="0">
                 <a:solidFill>
                   <a:srgbClr val="262626"/>
                 </a:solidFill>
                 <a:latin typeface="Arial"/>
               </a:rPr>
-              <a:t>Manually created files for a few MIs shared, to compare manual vs tool behaviour on the same setup.</a:t>
+              <a:t>Manual files shared for comparison</a:t>
             </a:r>
           </a:p>
         </p:txBody>
@@ -7261,8 +7133,8 @@
         </p:nvSpPr>
         <p:spPr>
           <a:xfrm>
-            <a:off x="6720840" y="4370832"/>
-            <a:ext cx="960120" cy="292608"/>
+            <a:off x="6556248" y="4233672"/>
+            <a:ext cx="1051560" cy="329184"/>
           </a:xfrm>
           <a:prstGeom prst="roundRect">
             <a:avLst>
@@ -7301,7 +7173,7 @@
               </a:spcAft>
             </a:pPr>
             <a:r>
-              <a:rPr sz="1000" b="1">
+              <a:rPr sz="1100" b="1">
                 <a:solidFill>
                   <a:srgbClr val="FFFFFF"/>
                 </a:solidFill>
@@ -7320,8 +7192,8 @@
         </p:nvSpPr>
         <p:spPr>
           <a:xfrm>
-            <a:off x="7772400" y="4151376"/>
-            <a:ext cx="3977639" cy="731520"/>
+            <a:off x="7726679" y="4078224"/>
+            <a:ext cx="4023360" cy="640080"/>
           </a:xfrm>
           <a:prstGeom prst="rect">
             <a:avLst/>
@@ -7340,13 +7212,13 @@
               </a:spcAft>
             </a:pPr>
             <a:r>
-              <a:rPr sz="1000" b="0">
+              <a:rPr sz="1400" b="0">
                 <a:solidFill>
                   <a:srgbClr val="262626"/>
                 </a:solidFill>
                 <a:latin typeface="Arial"/>
               </a:rPr>
-              <a:t>McD team at capacity until month-end; Meagan to set up a call early next week to discuss.</a:t>
+              <a:t>Pending – client team capacity</a:t>
             </a:r>
           </a:p>
         </p:txBody>
@@ -7359,8 +7231,8 @@
         </p:nvSpPr>
         <p:spPr>
           <a:xfrm>
-            <a:off x="411480" y="4956048"/>
-            <a:ext cx="11384280" cy="731520"/>
+            <a:off x="411480" y="4828031"/>
+            <a:ext cx="11384280" cy="640080"/>
           </a:xfrm>
           <a:prstGeom prst="rect">
             <a:avLst/>
@@ -7401,8 +7273,8 @@
         </p:nvSpPr>
         <p:spPr>
           <a:xfrm>
-            <a:off x="411480" y="4956048"/>
-            <a:ext cx="1143000" cy="731520"/>
+            <a:off x="411480" y="4828031"/>
+            <a:ext cx="1188720" cy="640080"/>
           </a:xfrm>
           <a:prstGeom prst="rect">
             <a:avLst/>
@@ -7410,18 +7282,18 @@
           <a:noFill/>
         </p:spPr>
         <p:txBody>
-          <a:bodyPr wrap="square" anchor="ctr" lIns="109728" rIns="109728" tIns="109728" bIns="109728">
+          <a:bodyPr wrap="square" anchor="ctr" lIns="128016" rIns="128016" tIns="128016" bIns="128016">
             <a:spAutoFit/>
           </a:bodyPr>
           <a:lstStyle/>
           <a:p>
             <a:pPr algn="l">
               <a:spcAft>
-                <a:spcPts val="0"/>
+                <a:spcPts val="200"/>
               </a:spcAft>
             </a:pPr>
             <a:r>
-              <a:rPr sz="1300" b="1">
+              <a:rPr sz="1400" b="1">
                 <a:solidFill>
                   <a:srgbClr val="096082"/>
                 </a:solidFill>
@@ -7430,22 +7302,6 @@
               <a:t>24 Sep</a:t>
             </a:r>
           </a:p>
-          <a:p>
-            <a:pPr algn="l">
-              <a:spcAft>
-                <a:spcPts val="0"/>
-              </a:spcAft>
-            </a:pPr>
-            <a:r>
-              <a:rPr sz="900" b="0">
-                <a:solidFill>
-                  <a:srgbClr val="595959"/>
-                </a:solidFill>
-                <a:latin typeface="Arial"/>
-              </a:rPr>
-              <a:t>2026</a:t>
-            </a:r>
-          </a:p>
         </p:txBody>
       </p:sp>
       <p:sp>
@@ -7456,8 +7312,8 @@
         </p:nvSpPr>
         <p:spPr>
           <a:xfrm>
-            <a:off x="1645920" y="4956048"/>
-            <a:ext cx="4892040" cy="731520"/>
+            <a:off x="1691640" y="4828031"/>
+            <a:ext cx="4663440" cy="640080"/>
           </a:xfrm>
           <a:prstGeom prst="rect">
             <a:avLst/>
@@ -7465,40 +7321,24 @@
           <a:noFill/>
         </p:spPr>
         <p:txBody>
-          <a:bodyPr wrap="square" anchor="ctr" tIns="91440" bIns="91440">
+          <a:bodyPr wrap="square" anchor="ctr" lIns="109728" rIns="109728" tIns="109728" bIns="109728">
             <a:spAutoFit/>
           </a:bodyPr>
           <a:lstStyle/>
           <a:p>
             <a:pPr algn="l">
               <a:spcAft>
-                <a:spcPts val="100"/>
+                <a:spcPts val="200"/>
               </a:spcAft>
             </a:pPr>
             <a:r>
-              <a:rPr sz="1100" b="1">
-                <a:solidFill>
-                  <a:srgbClr val="002060"/>
-                </a:solidFill>
-                <a:latin typeface="Arial"/>
-              </a:rPr>
-              <a:t>Internal – File-to-file validation</a:t>
-            </a:r>
-          </a:p>
-          <a:p>
-            <a:pPr algn="l">
-              <a:spcAft>
-                <a:spcPts val="100"/>
-              </a:spcAft>
-            </a:pPr>
-            <a:r>
-              <a:rPr sz="1000" b="0">
+              <a:rPr sz="1400" b="0">
                 <a:solidFill>
                   <a:srgbClr val="262626"/>
                 </a:solidFill>
                 <a:latin typeface="Arial"/>
               </a:rPr>
-              <a:t>Manual (18 Aug) vs tool (24 Sep) files compared for 3 MIs – 25786, 25789, 25837.</a:t>
+              <a:t>Manual vs tool file check (3 MIs)</a:t>
             </a:r>
           </a:p>
         </p:txBody>
@@ -7511,8 +7351,8 @@
         </p:nvSpPr>
         <p:spPr>
           <a:xfrm>
-            <a:off x="6720840" y="5175504"/>
-            <a:ext cx="960120" cy="292608"/>
+            <a:off x="6556248" y="4983479"/>
+            <a:ext cx="1051560" cy="329184"/>
           </a:xfrm>
           <a:prstGeom prst="roundRect">
             <a:avLst>
@@ -7551,7 +7391,7 @@
               </a:spcAft>
             </a:pPr>
             <a:r>
-              <a:rPr sz="1000" b="1">
+              <a:rPr sz="1100" b="1">
                 <a:solidFill>
                   <a:srgbClr val="FFFFFF"/>
                 </a:solidFill>
@@ -7570,8 +7410,8 @@
         </p:nvSpPr>
         <p:spPr>
           <a:xfrm>
-            <a:off x="7772400" y="4956048"/>
-            <a:ext cx="3977639" cy="731520"/>
+            <a:off x="7726679" y="4828031"/>
+            <a:ext cx="4023360" cy="640080"/>
           </a:xfrm>
           <a:prstGeom prst="rect">
             <a:avLst/>
@@ -7590,13 +7430,13 @@
               </a:spcAft>
             </a:pPr>
             <a:r>
-              <a:rPr sz="1000" b="0">
+              <a:rPr sz="1400" b="0">
                 <a:solidFill>
                   <a:srgbClr val="262626"/>
                 </a:solidFill>
                 <a:latin typeface="Arial"/>
               </a:rPr>
-              <a:t>All 14,085 stores, status, effective dates and prices match. *Format differs: BOM in manual header, leading spaces in tool PRICE_EATIN.</a:t>
+              <a:t>Data matches; *format differs</a:t>
             </a:r>
           </a:p>
         </p:txBody>
@@ -7609,8 +7449,8 @@
         </p:nvSpPr>
         <p:spPr>
           <a:xfrm>
-            <a:off x="411480" y="5797296"/>
-            <a:ext cx="11384280" cy="384048"/>
+            <a:off x="411480" y="5669279"/>
+            <a:ext cx="11384280" cy="457200"/>
           </a:xfrm>
           <a:prstGeom prst="rect">
             <a:avLst/>
@@ -7640,7 +7480,7 @@
           </a:fontRef>
         </p:style>
         <p:txBody>
-          <a:bodyPr rtlCol="0" anchor="ctr" wrap="square" lIns="109728" rIns="109728" tIns="109728" bIns="109728"/>
+          <a:bodyPr rtlCol="0" anchor="ctr" wrap="square" lIns="128016" rIns="128016" tIns="128016" bIns="128016"/>
           <a:lstStyle/>
           <a:p>
             <a:pPr algn="l">
@@ -7649,7 +7489,7 @@
               </a:spcAft>
             </a:pPr>
             <a:r>
-              <a:rPr sz="1100" b="1">
+              <a:rPr sz="1300" b="1">
                 <a:solidFill>
                   <a:srgbClr val="C00000"/>
                 </a:solidFill>
@@ -7658,13 +7498,13 @@
               <a:t>Current status: </a:t>
             </a:r>
             <a:r>
-              <a:rPr sz="1100" b="0">
+              <a:rPr sz="1300" b="0">
                 <a:solidFill>
                   <a:srgbClr val="262626"/>
                 </a:solidFill>
                 <a:latin typeface="Arial"/>
               </a:rPr>
-              <a:t>Round 1 worked, Rounds 2–3 showed no data. Root cause not yet found – 24 Sep format differences are the main lead.</a:t>
+              <a:t>Root cause not yet identified – file format differences are the main lead.</a:t>
             </a:r>
           </a:p>
         </p:txBody>
@@ -7716,8 +7556,8 @@
         </p:nvSpPr>
         <p:spPr>
           <a:xfrm>
-            <a:off x="411480" y="914400"/>
-            <a:ext cx="3611880" cy="4983480"/>
+            <a:off x="411480" y="960120"/>
+            <a:ext cx="3657600" cy="5074920"/>
           </a:xfrm>
           <a:prstGeom prst="rect">
             <a:avLst/>
@@ -7758,8 +7598,8 @@
         </p:nvSpPr>
         <p:spPr>
           <a:xfrm>
-            <a:off x="411480" y="914400"/>
-            <a:ext cx="3611880" cy="384048"/>
+            <a:off x="411480" y="960120"/>
+            <a:ext cx="3657600" cy="411480"/>
           </a:xfrm>
           <a:prstGeom prst="rect">
             <a:avLst/>
@@ -7796,13 +7636,13 @@
               </a:spcAft>
             </a:pPr>
             <a:r>
-              <a:rPr sz="1200" b="1">
+              <a:rPr sz="1300" b="1">
                 <a:solidFill>
                   <a:srgbClr val="FFFFFF"/>
                 </a:solidFill>
                 <a:latin typeface="Arial"/>
               </a:rPr>
-              <a:t>Step 1 – Fix tool output first</a:t>
+              <a:t>Step 1 – Fix tool output</a:t>
             </a:r>
           </a:p>
         </p:txBody>
@@ -7815,8 +7655,8 @@
         </p:nvSpPr>
         <p:spPr>
           <a:xfrm>
-            <a:off x="457200" y="1417320"/>
-            <a:ext cx="3520440" cy="2514600"/>
+            <a:off x="502920" y="1554480"/>
+            <a:ext cx="3474720" cy="2011680"/>
           </a:xfrm>
           <a:prstGeom prst="rect">
             <a:avLst/>
@@ -7829,127 +7669,75 @@
           </a:bodyPr>
           <a:lstStyle/>
           <a:p>
-            <a:pPr algn="l">
+            <a:pPr algn="l" marL="146304" indent="-146304">
               <a:spcAft>
-                <a:spcPts val="900"/>
+                <a:spcPts val="1200"/>
               </a:spcAft>
+              <a:buFont typeface="Arial"/>
+              <a:buChar char="•"/>
             </a:pPr>
             <a:r>
-              <a:rPr sz="1150" b="0">
+              <a:rPr sz="1400" b="0">
                 <a:solidFill>
                   <a:srgbClr val="262626"/>
                 </a:solidFill>
                 <a:latin typeface="Arial"/>
               </a:rPr>
-              <a:t>Make the tool file identical in format to the manual file that uploads successfully:</a:t>
+              <a:t>Remove leading spaces</a:t>
             </a:r>
           </a:p>
           <a:p>
             <a:pPr algn="l" marL="146304" indent="-146304">
               <a:spcAft>
-                <a:spcPts val="900"/>
+                <a:spcPts val="1200"/>
               </a:spcAft>
               <a:buFont typeface="Arial"/>
               <a:buChar char="•"/>
             </a:pPr>
             <a:r>
-              <a:rPr sz="1150" b="1">
-                <a:solidFill>
-                  <a:srgbClr val="002060"/>
-                </a:solidFill>
-                <a:latin typeface="Arial"/>
-              </a:rPr>
-              <a:t>Remove leading spaces </a:t>
-            </a:r>
-            <a:r>
-              <a:rPr sz="1150" b="0">
+              <a:rPr sz="1400" b="0">
                 <a:solidFill>
                   <a:srgbClr val="262626"/>
                 </a:solidFill>
                 <a:latin typeface="Arial"/>
               </a:rPr>
-              <a:t>from PRICE_EATIN values</a:t>
+              <a:t>Match UTF-8 BOM header</a:t>
             </a:r>
           </a:p>
           <a:p>
             <a:pPr algn="l" marL="146304" indent="-146304">
               <a:spcAft>
-                <a:spcPts val="900"/>
+                <a:spcPts val="1200"/>
               </a:spcAft>
               <a:buFont typeface="Arial"/>
               <a:buChar char="•"/>
             </a:pPr>
             <a:r>
-              <a:rPr sz="1150" b="1">
-                <a:solidFill>
-                  <a:srgbClr val="002060"/>
-                </a:solidFill>
-                <a:latin typeface="Arial"/>
-              </a:rPr>
-              <a:t>Match header encoding </a:t>
-            </a:r>
-            <a:r>
-              <a:rPr sz="1150" b="0">
+              <a:rPr sz="1400" b="0">
                 <a:solidFill>
                   <a:srgbClr val="262626"/>
                 </a:solidFill>
                 <a:latin typeface="Arial"/>
               </a:rPr>
-              <a:t>(UTF-8 BOM) of the manual CSV UTF-8 file</a:t>
+              <a:t>Match price format</a:t>
             </a:r>
           </a:p>
           <a:p>
             <a:pPr algn="l" marL="146304" indent="-146304">
               <a:spcAft>
-                <a:spcPts val="900"/>
+                <a:spcPts val="1200"/>
               </a:spcAft>
               <a:buFont typeface="Arial"/>
               <a:buChar char="•"/>
             </a:pPr>
             <a:r>
-              <a:rPr sz="1150" b="1">
-                <a:solidFill>
-                  <a:srgbClr val="002060"/>
-                </a:solidFill>
-                <a:latin typeface="Arial"/>
-              </a:rPr>
-              <a:t>Match price format </a:t>
-            </a:r>
-            <a:r>
-              <a:rPr sz="1150" b="0">
+              <a:rPr sz="1400" b="0">
                 <a:solidFill>
                   <a:srgbClr val="262626"/>
                 </a:solidFill>
                 <a:latin typeface="Arial"/>
               </a:rPr>
-              <a:t>(tool writes 5.10 / 5.00, manual has 5.1 / 5)</a:t>
-            </a:r>
-          </a:p>
-          <a:p>
-            <a:pPr algn="l" marL="146304" indent="-146304">
-              <a:spcAft>
-                <a:spcPts val="900"/>
-              </a:spcAft>
-              <a:buFont typeface="Arial"/>
-              <a:buChar char="•"/>
-            </a:pPr>
-            <a:r>
-              <a:rPr sz="1150" b="1">
-                <a:solidFill>
-                  <a:srgbClr val="002060"/>
-                </a:solidFill>
-                <a:latin typeface="Arial"/>
-              </a:rPr>
-              <a:t>Match line endings </a:t>
-            </a:r>
-            <a:r>
-              <a:rPr sz="1150" b="0">
-                <a:solidFill>
-                  <a:srgbClr val="262626"/>
-                </a:solidFill>
-                <a:latin typeface="Arial"/>
-              </a:rPr>
-              <a:t>(manual CRLF, tool LF)</a:t>
+              <a:t>Match line endings</a:t>
             </a:r>
           </a:p>
         </p:txBody>
@@ -7962,8 +7750,8 @@
         </p:nvSpPr>
         <p:spPr>
           <a:xfrm>
-            <a:off x="548640" y="3840480"/>
-            <a:ext cx="3337560" cy="1920240"/>
+            <a:off x="594360" y="3794760"/>
+            <a:ext cx="3291840" cy="2011680"/>
           </a:xfrm>
           <a:prstGeom prst="rect">
             <a:avLst/>
@@ -7996,13 +7784,13 @@
           <a:bodyPr rtlCol="0" anchor="ctr" wrap="square" lIns="128016" rIns="128016" tIns="128016" bIns="128016"/>
           <a:lstStyle/>
           <a:p>
-            <a:pPr algn="l">
+            <a:pPr algn="ctr">
               <a:spcAft>
-                <a:spcPts val="300"/>
+                <a:spcPts val="400"/>
               </a:spcAft>
             </a:pPr>
             <a:r>
-              <a:rPr sz="1100" b="1">
+              <a:rPr sz="1300" b="1">
                 <a:solidFill>
                   <a:srgbClr val="096082"/>
                 </a:solidFill>
@@ -8012,29 +7800,13 @@
             </a:r>
           </a:p>
           <a:p>
-            <a:pPr algn="l">
+            <a:pPr algn="ctr">
               <a:spcAft>
-                <a:spcPts val="300"/>
+                <a:spcPts val="400"/>
               </a:spcAft>
             </a:pPr>
             <a:r>
-              <a:rPr sz="1150" b="0">
-                <a:solidFill>
-                  <a:srgbClr val="262626"/>
-                </a:solidFill>
-                <a:latin typeface="Arial"/>
-              </a:rPr>
-              <a:t>Re-compare the fixed tool files with the manual files for the same MIs.</a:t>
-            </a:r>
-          </a:p>
-          <a:p>
-            <a:pPr algn="l">
-              <a:spcAft>
-                <a:spcPts val="300"/>
-              </a:spcAft>
-            </a:pPr>
-            <a:r>
-              <a:rPr sz="2000" b="1">
+              <a:rPr sz="2600" b="1">
                 <a:solidFill>
                   <a:srgbClr val="3B8A22"/>
                 </a:solidFill>
@@ -8044,19 +7816,19 @@
             </a:r>
           </a:p>
           <a:p>
-            <a:pPr algn="l">
+            <a:pPr algn="ctr">
               <a:spcAft>
-                <a:spcPts val="300"/>
+                <a:spcPts val="400"/>
               </a:spcAft>
             </a:pPr>
             <a:r>
-              <a:rPr sz="1000" b="0">
+              <a:rPr sz="1300" b="0">
                 <a:solidFill>
                   <a:srgbClr val="595959"/>
                 </a:solidFill>
                 <a:latin typeface="Arial"/>
               </a:rPr>
-              <a:t>in content AND format (byte-level match)</a:t>
+              <a:t>vs manual file</a:t>
             </a:r>
           </a:p>
         </p:txBody>
@@ -8069,8 +7841,8 @@
         </p:nvSpPr>
         <p:spPr>
           <a:xfrm>
-            <a:off x="4251960" y="914400"/>
-            <a:ext cx="7543800" cy="384048"/>
+            <a:off x="4297680" y="960120"/>
+            <a:ext cx="7498079" cy="411480"/>
           </a:xfrm>
           <a:prstGeom prst="rect">
             <a:avLst/>
@@ -8107,13 +7879,13 @@
               </a:spcAft>
             </a:pPr>
             <a:r>
-              <a:rPr sz="1200" b="1">
+              <a:rPr sz="1300" b="1">
                 <a:solidFill>
                   <a:srgbClr val="FFFFFF"/>
                 </a:solidFill>
                 <a:latin typeface="Arial"/>
               </a:rPr>
-              <a:t>Step 2 – Dashboard testing with McD team (Supreet)</a:t>
+              <a:t>Step 2 – Dashboard testing</a:t>
             </a:r>
           </a:p>
         </p:txBody>
@@ -8126,8 +7898,8 @@
         </p:nvSpPr>
         <p:spPr>
           <a:xfrm>
-            <a:off x="4251960" y="1371600"/>
-            <a:ext cx="3566160" cy="256032"/>
+            <a:off x="4800600" y="1463040"/>
+            <a:ext cx="3200400" cy="274320"/>
           </a:xfrm>
           <a:prstGeom prst="rect">
             <a:avLst/>
@@ -8135,7 +7907,7 @@
           <a:noFill/>
         </p:spPr>
         <p:txBody>
-          <a:bodyPr wrap="square" anchor="t" tIns="91440" bIns="91440">
+          <a:bodyPr wrap="square" anchor="t" lIns="73152" rIns="73152" tIns="73152" bIns="73152">
             <a:spAutoFit/>
           </a:bodyPr>
           <a:lstStyle/>
@@ -8146,7 +7918,7 @@
               </a:spcAft>
             </a:pPr>
             <a:r>
-              <a:rPr sz="1000" b="1">
+              <a:rPr sz="1100" b="1">
                 <a:solidFill>
                   <a:srgbClr val="595959"/>
                 </a:solidFill>
@@ -8165,8 +7937,8 @@
         </p:nvSpPr>
         <p:spPr>
           <a:xfrm>
-            <a:off x="8001000" y="1371600"/>
-            <a:ext cx="3749039" cy="256032"/>
+            <a:off x="8092440" y="1463040"/>
+            <a:ext cx="3566160" cy="274320"/>
           </a:xfrm>
           <a:prstGeom prst="rect">
             <a:avLst/>
@@ -8174,7 +7946,7 @@
           <a:noFill/>
         </p:spPr>
         <p:txBody>
-          <a:bodyPr wrap="square" anchor="t" tIns="91440" bIns="91440">
+          <a:bodyPr wrap="square" anchor="t" lIns="73152" rIns="73152" tIns="73152" bIns="73152">
             <a:spAutoFit/>
           </a:bodyPr>
           <a:lstStyle/>
@@ -8185,7 +7957,7 @@
               </a:spcAft>
             </a:pPr>
             <a:r>
-              <a:rPr sz="1000" b="1">
+              <a:rPr sz="1100" b="1">
                 <a:solidFill>
                   <a:srgbClr val="595959"/>
                 </a:solidFill>
@@ -8204,8 +7976,8 @@
         </p:nvSpPr>
         <p:spPr>
           <a:xfrm>
-            <a:off x="4251960" y="1664208"/>
-            <a:ext cx="7543800" cy="676656"/>
+            <a:off x="4297680" y="1783080"/>
+            <a:ext cx="7498079" cy="621792"/>
           </a:xfrm>
           <a:prstGeom prst="rect">
             <a:avLst/>
@@ -8246,8 +8018,8 @@
         </p:nvSpPr>
         <p:spPr>
           <a:xfrm>
-            <a:off x="4343400" y="1828800"/>
-            <a:ext cx="347472" cy="347472"/>
+            <a:off x="4389120" y="1911096"/>
+            <a:ext cx="365760" cy="365760"/>
           </a:xfrm>
           <a:prstGeom prst="ellipse">
             <a:avLst/>
@@ -8284,7 +8056,7 @@
               </a:spcAft>
             </a:pPr>
             <a:r>
-              <a:rPr sz="1200" b="1">
+              <a:rPr sz="1300" b="1">
                 <a:solidFill>
                   <a:srgbClr val="002060"/>
                 </a:solidFill>
@@ -8303,8 +8075,8 @@
         </p:nvSpPr>
         <p:spPr>
           <a:xfrm>
-            <a:off x="4754880" y="1664208"/>
-            <a:ext cx="3200400" cy="676656"/>
+            <a:off x="4800600" y="1783080"/>
+            <a:ext cx="3246120" cy="621792"/>
           </a:xfrm>
           <a:prstGeom prst="rect">
             <a:avLst/>
@@ -8319,33 +8091,17 @@
           <a:p>
             <a:pPr algn="l">
               <a:spcAft>
-                <a:spcPts val="100"/>
+                <a:spcPts val="200"/>
               </a:spcAft>
             </a:pPr>
             <a:r>
-              <a:rPr sz="1100" b="1">
-                <a:solidFill>
-                  <a:srgbClr val="002060"/>
-                </a:solidFill>
-                <a:latin typeface="Arial"/>
-              </a:rPr>
-              <a:t>Baseline: manual file upload</a:t>
-            </a:r>
-          </a:p>
-          <a:p>
-            <a:pPr algn="l">
-              <a:spcAft>
-                <a:spcPts val="100"/>
-              </a:spcAft>
-            </a:pPr>
-            <a:r>
-              <a:rPr sz="950" b="0">
+              <a:rPr sz="1400" b="0">
                 <a:solidFill>
                   <a:srgbClr val="262626"/>
                 </a:solidFill>
                 <a:latin typeface="Arial"/>
               </a:rPr>
-              <a:t>Upload the manual files shared on 22 Sep for a test MI.</a:t>
+              <a:t>Manual file upload (baseline)</a:t>
             </a:r>
           </a:p>
         </p:txBody>
@@ -8358,8 +8114,8 @@
         </p:nvSpPr>
         <p:spPr>
           <a:xfrm>
-            <a:off x="8046720" y="1737360"/>
-            <a:ext cx="3639312" cy="530352"/>
+            <a:off x="8092440" y="1874520"/>
+            <a:ext cx="3611880" cy="438912"/>
           </a:xfrm>
           <a:prstGeom prst="rect">
             <a:avLst/>
@@ -8396,7 +8152,7 @@
               </a:spcAft>
             </a:pPr>
             <a:r>
-              <a:rPr sz="1000" b="1">
+              <a:rPr sz="1300" b="1">
                 <a:solidFill>
                   <a:srgbClr val="3B8A22"/>
                 </a:solidFill>
@@ -8405,13 +8161,13 @@
               <a:t>✔ </a:t>
             </a:r>
             <a:r>
-              <a:rPr sz="1000" b="0">
+              <a:rPr sz="1300" b="0">
                 <a:solidFill>
                   <a:srgbClr val="262626"/>
                 </a:solidFill>
                 <a:latin typeface="Arial"/>
               </a:rPr>
-              <a:t>Data shows in Cosmos &amp; Power BI – confirms the test setup itself works.</a:t>
+              <a:t>Data visible in Cosmos &amp; Power BI</a:t>
             </a:r>
           </a:p>
         </p:txBody>
@@ -8424,8 +8180,8 @@
         </p:nvSpPr>
         <p:spPr>
           <a:xfrm>
-            <a:off x="4251960" y="2414016"/>
-            <a:ext cx="7543800" cy="676656"/>
+            <a:off x="4297680" y="2514600"/>
+            <a:ext cx="7498079" cy="621792"/>
           </a:xfrm>
           <a:prstGeom prst="rect">
             <a:avLst/>
@@ -8466,8 +8222,8 @@
         </p:nvSpPr>
         <p:spPr>
           <a:xfrm>
-            <a:off x="4343400" y="2578608"/>
-            <a:ext cx="347472" cy="347472"/>
+            <a:off x="4389120" y="2642616"/>
+            <a:ext cx="365760" cy="365760"/>
           </a:xfrm>
           <a:prstGeom prst="ellipse">
             <a:avLst/>
@@ -8504,7 +8260,7 @@
               </a:spcAft>
             </a:pPr>
             <a:r>
-              <a:rPr sz="1200" b="1">
+              <a:rPr sz="1300" b="1">
                 <a:solidFill>
                   <a:srgbClr val="002060"/>
                 </a:solidFill>
@@ -8523,8 +8279,8 @@
         </p:nvSpPr>
         <p:spPr>
           <a:xfrm>
-            <a:off x="4754880" y="2414016"/>
-            <a:ext cx="3200400" cy="676656"/>
+            <a:off x="4800600" y="2514600"/>
+            <a:ext cx="3246120" cy="621792"/>
           </a:xfrm>
           <a:prstGeom prst="rect">
             <a:avLst/>
@@ -8539,33 +8295,17 @@
           <a:p>
             <a:pPr algn="l">
               <a:spcAft>
-                <a:spcPts val="100"/>
+                <a:spcPts val="200"/>
               </a:spcAft>
             </a:pPr>
             <a:r>
-              <a:rPr sz="1100" b="1">
-                <a:solidFill>
-                  <a:srgbClr val="002060"/>
-                </a:solidFill>
-                <a:latin typeface="Arial"/>
-              </a:rPr>
-              <a:t>Fixed tool file – same MI</a:t>
-            </a:r>
-          </a:p>
-          <a:p>
-            <a:pPr algn="l">
-              <a:spcAft>
-                <a:spcPts val="100"/>
-              </a:spcAft>
-            </a:pPr>
-            <a:r>
-              <a:rPr sz="950" b="0">
+              <a:rPr sz="1400" b="0">
                 <a:solidFill>
                   <a:srgbClr val="262626"/>
                 </a:solidFill>
                 <a:latin typeface="Arial"/>
               </a:rPr>
-              <a:t>Upload the corrected tool file for an equivalent new test MI.</a:t>
+              <a:t>Fixed tool file – new MI</a:t>
             </a:r>
           </a:p>
         </p:txBody>
@@ -8578,8 +8318,8 @@
         </p:nvSpPr>
         <p:spPr>
           <a:xfrm>
-            <a:off x="8046720" y="2487168"/>
-            <a:ext cx="3639312" cy="530352"/>
+            <a:off x="8092440" y="2606040"/>
+            <a:ext cx="3611880" cy="438912"/>
           </a:xfrm>
           <a:prstGeom prst="rect">
             <a:avLst/>
@@ -8616,7 +8356,7 @@
               </a:spcAft>
             </a:pPr>
             <a:r>
-              <a:rPr sz="1000" b="1">
+              <a:rPr sz="1300" b="1">
                 <a:solidFill>
                   <a:srgbClr val="3B8A22"/>
                 </a:solidFill>
@@ -8625,13 +8365,13 @@
               <a:t>✔ </a:t>
             </a:r>
             <a:r>
-              <a:rPr sz="1000" b="0">
+              <a:rPr sz="1300" b="0">
                 <a:solidFill>
                   <a:srgbClr val="262626"/>
                 </a:solidFill>
                 <a:latin typeface="Arial"/>
               </a:rPr>
-              <a:t>Data populates in Cosmos &amp; Power BI exactly like the manual file.</a:t>
+              <a:t>Same result as manual file</a:t>
             </a:r>
           </a:p>
         </p:txBody>
@@ -8644,8 +8384,8 @@
         </p:nvSpPr>
         <p:spPr>
           <a:xfrm>
-            <a:off x="4251960" y="3163824"/>
-            <a:ext cx="7543800" cy="676656"/>
+            <a:off x="4297680" y="3246120"/>
+            <a:ext cx="7498079" cy="621792"/>
           </a:xfrm>
           <a:prstGeom prst="rect">
             <a:avLst/>
@@ -8686,8 +8426,8 @@
         </p:nvSpPr>
         <p:spPr>
           <a:xfrm>
-            <a:off x="4343400" y="3328416"/>
-            <a:ext cx="347472" cy="347472"/>
+            <a:off x="4389120" y="3374136"/>
+            <a:ext cx="365760" cy="365760"/>
           </a:xfrm>
           <a:prstGeom prst="ellipse">
             <a:avLst/>
@@ -8724,7 +8464,7 @@
               </a:spcAft>
             </a:pPr>
             <a:r>
-              <a:rPr sz="1200" b="1">
+              <a:rPr sz="1300" b="1">
                 <a:solidFill>
                   <a:srgbClr val="002060"/>
                 </a:solidFill>
@@ -8743,8 +8483,8 @@
         </p:nvSpPr>
         <p:spPr>
           <a:xfrm>
-            <a:off x="4754880" y="3163824"/>
-            <a:ext cx="3200400" cy="676656"/>
+            <a:off x="4800600" y="3246120"/>
+            <a:ext cx="3246120" cy="621792"/>
           </a:xfrm>
           <a:prstGeom prst="rect">
             <a:avLst/>
@@ -8759,33 +8499,17 @@
           <a:p>
             <a:pPr algn="l">
               <a:spcAft>
-                <a:spcPts val="100"/>
+                <a:spcPts val="200"/>
               </a:spcAft>
             </a:pPr>
             <a:r>
-              <a:rPr sz="1100" b="1">
-                <a:solidFill>
-                  <a:srgbClr val="002060"/>
-                </a:solidFill>
-                <a:latin typeface="Arial"/>
-              </a:rPr>
-              <a:t>Existing / older MI</a:t>
-            </a:r>
-          </a:p>
-          <a:p>
-            <a:pPr algn="l">
-              <a:spcAft>
-                <a:spcPts val="100"/>
-              </a:spcAft>
-            </a:pPr>
-            <a:r>
-              <a:rPr sz="950" b="0">
+              <a:rPr sz="1400" b="0">
                 <a:solidFill>
                   <a:srgbClr val="262626"/>
                 </a:solidFill>
                 <a:latin typeface="Arial"/>
               </a:rPr>
-              <a:t>Re-test an existing MI (e.g., MI 5) with the corrected file.</a:t>
+              <a:t>Fixed tool file – existing MI</a:t>
             </a:r>
           </a:p>
         </p:txBody>
@@ -8798,8 +8522,8 @@
         </p:nvSpPr>
         <p:spPr>
           <a:xfrm>
-            <a:off x="8046720" y="3236976"/>
-            <a:ext cx="3639312" cy="530352"/>
+            <a:off x="8092440" y="3337560"/>
+            <a:ext cx="3611880" cy="438912"/>
           </a:xfrm>
           <a:prstGeom prst="rect">
             <a:avLst/>
@@ -8836,7 +8560,7 @@
               </a:spcAft>
             </a:pPr>
             <a:r>
-              <a:rPr sz="1000" b="1">
+              <a:rPr sz="1300" b="1">
                 <a:solidFill>
                   <a:srgbClr val="3B8A22"/>
                 </a:solidFill>
@@ -8845,13 +8569,13 @@
               <a:t>✔ </a:t>
             </a:r>
             <a:r>
-              <a:rPr sz="1000" b="0">
+              <a:rPr sz="1300" b="0">
                 <a:solidFill>
                   <a:srgbClr val="262626"/>
                 </a:solidFill>
                 <a:latin typeface="Arial"/>
               </a:rPr>
-              <a:t>Data populates – no difference between new and existing MIs.</a:t>
+              <a:t>Data populates correctly</a:t>
             </a:r>
           </a:p>
         </p:txBody>
@@ -8864,8 +8588,8 @@
         </p:nvSpPr>
         <p:spPr>
           <a:xfrm>
-            <a:off x="4251960" y="3913632"/>
-            <a:ext cx="7543800" cy="676656"/>
+            <a:off x="4297680" y="3977640"/>
+            <a:ext cx="7498079" cy="621792"/>
           </a:xfrm>
           <a:prstGeom prst="rect">
             <a:avLst/>
@@ -8906,8 +8630,8 @@
         </p:nvSpPr>
         <p:spPr>
           <a:xfrm>
-            <a:off x="4343400" y="4078224"/>
-            <a:ext cx="347472" cy="347472"/>
+            <a:off x="4389120" y="4105656"/>
+            <a:ext cx="365760" cy="365760"/>
           </a:xfrm>
           <a:prstGeom prst="ellipse">
             <a:avLst/>
@@ -8944,7 +8668,7 @@
               </a:spcAft>
             </a:pPr>
             <a:r>
-              <a:rPr sz="1200" b="1">
+              <a:rPr sz="1300" b="1">
                 <a:solidFill>
                   <a:srgbClr val="002060"/>
                 </a:solidFill>
@@ -8963,8 +8687,8 @@
         </p:nvSpPr>
         <p:spPr>
           <a:xfrm>
-            <a:off x="4754880" y="3913632"/>
-            <a:ext cx="3200400" cy="676656"/>
+            <a:off x="4800600" y="3977640"/>
+            <a:ext cx="3246120" cy="621792"/>
           </a:xfrm>
           <a:prstGeom prst="rect">
             <a:avLst/>
@@ -8979,33 +8703,17 @@
           <a:p>
             <a:pPr algn="l">
               <a:spcAft>
-                <a:spcPts val="100"/>
+                <a:spcPts val="200"/>
               </a:spcAft>
             </a:pPr>
             <a:r>
-              <a:rPr sz="1100" b="1">
-                <a:solidFill>
-                  <a:srgbClr val="002060"/>
-                </a:solidFill>
-                <a:latin typeface="Arial"/>
-              </a:rPr>
-              <a:t>Activation % check</a:t>
-            </a:r>
-          </a:p>
-          <a:p>
-            <a:pPr algn="l">
-              <a:spcAft>
-                <a:spcPts val="100"/>
-              </a:spcAft>
-            </a:pPr>
-            <a:r>
-              <a:rPr sz="950" b="0">
+              <a:rPr sz="1400" b="0">
                 <a:solidFill>
                   <a:srgbClr val="262626"/>
                 </a:solidFill>
                 <a:latin typeface="Arial"/>
               </a:rPr>
-              <a:t>Single upload on a fresh test MI, compare dashboard % with file %.</a:t>
+              <a:t>Activation % check</a:t>
             </a:r>
           </a:p>
         </p:txBody>
@@ -9018,8 +8726,8 @@
         </p:nvSpPr>
         <p:spPr>
           <a:xfrm>
-            <a:off x="8046720" y="3986784"/>
-            <a:ext cx="3639312" cy="530352"/>
+            <a:off x="8092440" y="4069080"/>
+            <a:ext cx="3611880" cy="438912"/>
           </a:xfrm>
           <a:prstGeom prst="rect">
             <a:avLst/>
@@ -9056,7 +8764,7 @@
               </a:spcAft>
             </a:pPr>
             <a:r>
-              <a:rPr sz="1000" b="1">
+              <a:rPr sz="1300" b="1">
                 <a:solidFill>
                   <a:srgbClr val="3B8A22"/>
                 </a:solidFill>
@@ -9065,13 +8773,13 @@
               <a:t>✔ </a:t>
             </a:r>
             <a:r>
-              <a:rPr sz="1000" b="0">
+              <a:rPr sz="1300" b="0">
                 <a:solidFill>
                   <a:srgbClr val="262626"/>
                 </a:solidFill>
                 <a:latin typeface="Arial"/>
               </a:rPr>
-              <a:t>Dashboard % equals file-calculated % (e.g., 92%, not an older 98%).</a:t>
+              <a:t>Dashboard % = file %</a:t>
             </a:r>
           </a:p>
         </p:txBody>
@@ -9084,8 +8792,8 @@
         </p:nvSpPr>
         <p:spPr>
           <a:xfrm>
-            <a:off x="4251960" y="4663440"/>
-            <a:ext cx="7543800" cy="676656"/>
+            <a:off x="4297680" y="4709160"/>
+            <a:ext cx="7498079" cy="621792"/>
           </a:xfrm>
           <a:prstGeom prst="rect">
             <a:avLst/>
@@ -9126,8 +8834,8 @@
         </p:nvSpPr>
         <p:spPr>
           <a:xfrm>
-            <a:off x="4343400" y="4828031"/>
-            <a:ext cx="347472" cy="347472"/>
+            <a:off x="4389120" y="4837176"/>
+            <a:ext cx="365760" cy="365760"/>
           </a:xfrm>
           <a:prstGeom prst="ellipse">
             <a:avLst/>
@@ -9164,7 +8872,7 @@
               </a:spcAft>
             </a:pPr>
             <a:r>
-              <a:rPr sz="1200" b="1">
+              <a:rPr sz="1300" b="1">
                 <a:solidFill>
                   <a:srgbClr val="002060"/>
                 </a:solidFill>
@@ -9183,8 +8891,8 @@
         </p:nvSpPr>
         <p:spPr>
           <a:xfrm>
-            <a:off x="4754880" y="4663440"/>
-            <a:ext cx="3200400" cy="676656"/>
+            <a:off x="4800600" y="4709160"/>
+            <a:ext cx="3246120" cy="621792"/>
           </a:xfrm>
           <a:prstGeom prst="rect">
             <a:avLst/>
@@ -9199,33 +8907,17 @@
           <a:p>
             <a:pPr algn="l">
               <a:spcAft>
-                <a:spcPts val="100"/>
+                <a:spcPts val="200"/>
               </a:spcAft>
             </a:pPr>
             <a:r>
-              <a:rPr sz="1100" b="1">
-                <a:solidFill>
-                  <a:srgbClr val="002060"/>
-                </a:solidFill>
-                <a:latin typeface="Arial"/>
-              </a:rPr>
-              <a:t>Multiple MIs in one run</a:t>
-            </a:r>
-          </a:p>
-          <a:p>
-            <a:pPr algn="l">
-              <a:spcAft>
-                <a:spcPts val="100"/>
-              </a:spcAft>
-            </a:pPr>
-            <a:r>
-              <a:rPr sz="950" b="0">
+              <a:rPr sz="1400" b="0">
                 <a:solidFill>
                   <a:srgbClr val="262626"/>
                 </a:solidFill>
                 <a:latin typeface="Arial"/>
               </a:rPr>
-              <a:t>Upload a batch of tool files generated in one go.</a:t>
+              <a:t>Multiple MIs in one run</a:t>
             </a:r>
           </a:p>
         </p:txBody>
@@ -9238,8 +8930,8 @@
         </p:nvSpPr>
         <p:spPr>
           <a:xfrm>
-            <a:off x="8046720" y="4736592"/>
-            <a:ext cx="3639312" cy="530352"/>
+            <a:off x="8092440" y="4800600"/>
+            <a:ext cx="3611880" cy="438912"/>
           </a:xfrm>
           <a:prstGeom prst="rect">
             <a:avLst/>
@@ -9276,7 +8968,7 @@
               </a:spcAft>
             </a:pPr>
             <a:r>
-              <a:rPr sz="1000" b="1">
+              <a:rPr sz="1300" b="1">
                 <a:solidFill>
                   <a:srgbClr val="3B8A22"/>
                 </a:solidFill>
@@ -9285,13 +8977,13 @@
               <a:t>✔ </a:t>
             </a:r>
             <a:r>
-              <a:rPr sz="1000" b="0">
+              <a:rPr sz="1300" b="0">
                 <a:solidFill>
                   <a:srgbClr val="262626"/>
                 </a:solidFill>
                 <a:latin typeface="Arial"/>
               </a:rPr>
-              <a:t>Every MI reflects correctly on the dashboard.</a:t>
+              <a:t>All MIs reflect correctly</a:t>
             </a:r>
           </a:p>
         </p:txBody>
@@ -9304,8 +8996,8 @@
         </p:nvSpPr>
         <p:spPr>
           <a:xfrm>
-            <a:off x="4251960" y="5513832"/>
-            <a:ext cx="7543800" cy="384048"/>
+            <a:off x="4297680" y="5577840"/>
+            <a:ext cx="7498079" cy="457200"/>
           </a:xfrm>
           <a:prstGeom prst="rect">
             <a:avLst/>
@@ -9335,7 +9027,7 @@
           </a:fontRef>
         </p:style>
         <p:txBody>
-          <a:bodyPr rtlCol="0" anchor="ctr" wrap="square" lIns="109728" rIns="109728" tIns="109728" bIns="109728"/>
+          <a:bodyPr rtlCol="0" anchor="ctr" wrap="square" lIns="128016" rIns="128016" tIns="128016" bIns="128016"/>
           <a:lstStyle/>
           <a:p>
             <a:pPr algn="l">
@@ -9344,7 +9036,7 @@
               </a:spcAft>
             </a:pPr>
             <a:r>
-              <a:rPr sz="1100" b="1">
+              <a:rPr sz="1300" b="1">
                 <a:solidFill>
                   <a:srgbClr val="C00000"/>
                 </a:solidFill>
@@ -9353,13 +9045,13 @@
               <a:t>Target: </a:t>
             </a:r>
             <a:r>
-              <a:rPr sz="1100" b="0">
+              <a:rPr sz="1300" b="0">
                 <a:solidFill>
                   <a:srgbClr val="262626"/>
                 </a:solidFill>
                 <a:latin typeface="Arial"/>
               </a:rPr>
-              <a:t>Go/No-Go before end-October campaign – then tool files replace manual prep (75 → 2 min/MI).</a:t>
+              <a:t>Go/No-Go before end-October campaign</a:t>
             </a:r>
           </a:p>
         </p:txBody>

</xml_diff>